<commit_message>
feat: complete UI revamp for Purplle theme and integrate Store 2 data
</commit_message>
<xml_diff>
--- a/Purplle_Store_Intelligence_PRIS.pptx
+++ b/Purplle_Store_Intelligence_PRIS.pptx
@@ -15,6 +15,7 @@
     <p:sldId id="263" r:id="rId14"/>
     <p:sldId id="264" r:id="rId15"/>
     <p:sldId id="265" r:id="rId16"/>
+    <p:sldId id="266" r:id="rId17"/>
   </p:sldIdLst>
   <p:sldSz cx="12191695" cy="6858000" type="screen4x3"/>
   <p:notesSz cx="6858000" cy="9144000"/>
@@ -3213,7 +3214,7 @@
               </a:defRPr>
             </a:pPr>
             <a:r>
-              <a:t>Presented by: Himadri</a:t>
+              <a:t>Presented by: Himadri Mani</a:t>
             </a:r>
           </a:p>
         </p:txBody>
@@ -3428,6 +3429,113 @@
                 </a:solidFill>
               </a:rPr>
               <a:t>Contains structural blue-prints, detailed API endpoints maps, developer setup guides, and troubleshooting procedures.</a:t>
+            </a:r>
+          </a:p>
+        </p:txBody>
+      </p:sp>
+    </p:spTree>
+  </p:cSld>
+  <p:clrMapOvr>
+    <a:masterClrMapping/>
+  </p:clrMapOvr>
+</p:sld>
+</file>
+
+<file path=ppt/slides/slide11.xml><?xml version="1.0" encoding="utf-8"?>
+<p:sld xmlns:a="http://schemas.openxmlformats.org/drawingml/2006/main" xmlns:p="http://schemas.openxmlformats.org/presentationml/2006/main" xmlns:r="http://schemas.openxmlformats.org/officeDocument/2006/relationships">
+  <p:cSld>
+    <p:bg>
+      <p:bgPr>
+        <a:solidFill>
+          <a:srgbClr val="0F0F14"/>
+        </a:solidFill>
+        <a:effectLst/>
+      </p:bgPr>
+    </p:bg>
+    <p:spTree>
+      <p:nvGrpSpPr>
+        <p:cNvPr id="1" name=""/>
+        <p:cNvGrpSpPr/>
+        <p:nvPr/>
+      </p:nvGrpSpPr>
+      <p:grpSpPr/>
+      <p:sp>
+        <p:nvSpPr>
+          <p:cNvPr id="2" name="Rectangle 1"/>
+          <p:cNvSpPr/>
+          <p:nvPr/>
+        </p:nvSpPr>
+        <p:spPr>
+          <a:xfrm>
+            <a:off x="0" y="0"/>
+            <a:ext cx="12191695" cy="91440"/>
+          </a:xfrm>
+          <a:prstGeom prst="rect">
+            <a:avLst/>
+          </a:prstGeom>
+          <a:solidFill>
+            <a:srgbClr val="8A2BE2"/>
+          </a:solidFill>
+          <a:ln>
+            <a:solidFill>
+              <a:srgbClr val="8A2BE2"/>
+            </a:solidFill>
+          </a:ln>
+        </p:spPr>
+        <p:style>
+          <a:lnRef idx="1">
+            <a:schemeClr val="accent1"/>
+          </a:lnRef>
+          <a:fillRef idx="3">
+            <a:schemeClr val="accent1"/>
+          </a:fillRef>
+          <a:effectRef idx="2">
+            <a:schemeClr val="accent1"/>
+          </a:effectRef>
+          <a:fontRef idx="minor">
+            <a:schemeClr val="lt1"/>
+          </a:fontRef>
+        </p:style>
+        <p:txBody>
+          <a:bodyPr rtlCol="0" anchor="ctr"/>
+          <a:lstStyle/>
+          <a:p>
+            <a:pPr algn="ctr"/>
+          </a:p>
+        </p:txBody>
+      </p:sp>
+      <p:sp>
+        <p:nvSpPr>
+          <p:cNvPr id="3" name="TextBox 2"/>
+          <p:cNvSpPr txBox="1"/>
+          <p:nvPr/>
+        </p:nvSpPr>
+        <p:spPr>
+          <a:xfrm>
+            <a:off x="0" y="2743200"/>
+            <a:ext cx="12191695" cy="1371600"/>
+          </a:xfrm>
+          <a:prstGeom prst="rect">
+            <a:avLst/>
+          </a:prstGeom>
+          <a:noFill/>
+        </p:spPr>
+        <p:txBody>
+          <a:bodyPr wrap="square">
+            <a:spAutoFit/>
+          </a:bodyPr>
+          <a:lstStyle/>
+          <a:p>
+            <a:pPr algn="ctr">
+              <a:defRPr sz="6000" b="1">
+                <a:solidFill>
+                  <a:srgbClr val="8A2BE2"/>
+                </a:solidFill>
+                <a:latin typeface="Arial"/>
+              </a:defRPr>
+            </a:pPr>
+            <a:r>
+              <a:t>Thank You!</a:t>
             </a:r>
           </a:p>
         </p:txBody>

</xml_diff>